<commit_message>
Sync: Add/Update tbb-LPSCI folder - 2026-04-29 20:50
</commit_message>
<xml_diff>
--- a/tbb-LPSCI/Li6PS5ClxI1-x.pptx
+++ b/tbb-LPSCI/Li6PS5ClxI1-x.pptx
@@ -6,6 +6,7 @@
   </p:sldMasterIdLst>
   <p:sldIdLst>
     <p:sldId id="256" r:id="rId2"/>
+    <p:sldId id="257" r:id="rId3"/>
   </p:sldIdLst>
   <p:sldSz cx="12192000" cy="6858000"/>
   <p:notesSz cx="6858000" cy="9144000"/>
@@ -104,6 +105,11 @@
       </a:defRPr>
     </a:lvl9pPr>
   </p:defaultTextStyle>
+  <p:extLst>
+    <p:ext uri="{EFAFB233-063F-42B5-8137-9DF3F51BA10A}">
+      <p15:sldGuideLst xmlns:p15="http://schemas.microsoft.com/office/powerpoint/2012/main"/>
+    </p:ext>
+  </p:extLst>
 </p:presentation>
 </file>
 
@@ -254,7 +260,7 @@
           <a:p>
             <a:fld id="{62FD83A5-3698-4B55-AAEC-77F39706C6D9}" type="datetimeFigureOut">
               <a:rPr lang="zh-CN" altLang="en-US" smtClean="0"/>
-              <a:t>2026/4/28</a:t>
+              <a:t>2026/4/29</a:t>
             </a:fld>
             <a:endParaRPr lang="zh-CN" altLang="en-US"/>
           </a:p>
@@ -452,7 +458,7 @@
           <a:p>
             <a:fld id="{62FD83A5-3698-4B55-AAEC-77F39706C6D9}" type="datetimeFigureOut">
               <a:rPr lang="zh-CN" altLang="en-US" smtClean="0"/>
-              <a:t>2026/4/28</a:t>
+              <a:t>2026/4/29</a:t>
             </a:fld>
             <a:endParaRPr lang="zh-CN" altLang="en-US"/>
           </a:p>
@@ -660,7 +666,7 @@
           <a:p>
             <a:fld id="{62FD83A5-3698-4B55-AAEC-77F39706C6D9}" type="datetimeFigureOut">
               <a:rPr lang="zh-CN" altLang="en-US" smtClean="0"/>
-              <a:t>2026/4/28</a:t>
+              <a:t>2026/4/29</a:t>
             </a:fld>
             <a:endParaRPr lang="zh-CN" altLang="en-US"/>
           </a:p>
@@ -858,7 +864,7 @@
           <a:p>
             <a:fld id="{62FD83A5-3698-4B55-AAEC-77F39706C6D9}" type="datetimeFigureOut">
               <a:rPr lang="zh-CN" altLang="en-US" smtClean="0"/>
-              <a:t>2026/4/28</a:t>
+              <a:t>2026/4/29</a:t>
             </a:fld>
             <a:endParaRPr lang="zh-CN" altLang="en-US"/>
           </a:p>
@@ -1133,7 +1139,7 @@
           <a:p>
             <a:fld id="{62FD83A5-3698-4B55-AAEC-77F39706C6D9}" type="datetimeFigureOut">
               <a:rPr lang="zh-CN" altLang="en-US" smtClean="0"/>
-              <a:t>2026/4/28</a:t>
+              <a:t>2026/4/29</a:t>
             </a:fld>
             <a:endParaRPr lang="zh-CN" altLang="en-US"/>
           </a:p>
@@ -1398,7 +1404,7 @@
           <a:p>
             <a:fld id="{62FD83A5-3698-4B55-AAEC-77F39706C6D9}" type="datetimeFigureOut">
               <a:rPr lang="zh-CN" altLang="en-US" smtClean="0"/>
-              <a:t>2026/4/28</a:t>
+              <a:t>2026/4/29</a:t>
             </a:fld>
             <a:endParaRPr lang="zh-CN" altLang="en-US"/>
           </a:p>
@@ -1810,7 +1816,7 @@
           <a:p>
             <a:fld id="{62FD83A5-3698-4B55-AAEC-77F39706C6D9}" type="datetimeFigureOut">
               <a:rPr lang="zh-CN" altLang="en-US" smtClean="0"/>
-              <a:t>2026/4/28</a:t>
+              <a:t>2026/4/29</a:t>
             </a:fld>
             <a:endParaRPr lang="zh-CN" altLang="en-US"/>
           </a:p>
@@ -1951,7 +1957,7 @@
           <a:p>
             <a:fld id="{62FD83A5-3698-4B55-AAEC-77F39706C6D9}" type="datetimeFigureOut">
               <a:rPr lang="zh-CN" altLang="en-US" smtClean="0"/>
-              <a:t>2026/4/28</a:t>
+              <a:t>2026/4/29</a:t>
             </a:fld>
             <a:endParaRPr lang="zh-CN" altLang="en-US"/>
           </a:p>
@@ -2064,7 +2070,7 @@
           <a:p>
             <a:fld id="{62FD83A5-3698-4B55-AAEC-77F39706C6D9}" type="datetimeFigureOut">
               <a:rPr lang="zh-CN" altLang="en-US" smtClean="0"/>
-              <a:t>2026/4/28</a:t>
+              <a:t>2026/4/29</a:t>
             </a:fld>
             <a:endParaRPr lang="zh-CN" altLang="en-US"/>
           </a:p>
@@ -2375,7 +2381,7 @@
           <a:p>
             <a:fld id="{62FD83A5-3698-4B55-AAEC-77F39706C6D9}" type="datetimeFigureOut">
               <a:rPr lang="zh-CN" altLang="en-US" smtClean="0"/>
-              <a:t>2026/4/28</a:t>
+              <a:t>2026/4/29</a:t>
             </a:fld>
             <a:endParaRPr lang="zh-CN" altLang="en-US"/>
           </a:p>
@@ -2663,7 +2669,7 @@
           <a:p>
             <a:fld id="{62FD83A5-3698-4B55-AAEC-77F39706C6D9}" type="datetimeFigureOut">
               <a:rPr lang="zh-CN" altLang="en-US" smtClean="0"/>
-              <a:t>2026/4/28</a:t>
+              <a:t>2026/4/29</a:t>
             </a:fld>
             <a:endParaRPr lang="zh-CN" altLang="en-US"/>
           </a:p>
@@ -2904,7 +2910,7 @@
           <a:p>
             <a:fld id="{62FD83A5-3698-4B55-AAEC-77F39706C6D9}" type="datetimeFigureOut">
               <a:rPr lang="zh-CN" altLang="en-US" smtClean="0"/>
-              <a:t>2026/4/28</a:t>
+              <a:t>2026/4/29</a:t>
             </a:fld>
             <a:endParaRPr lang="zh-CN" altLang="en-US"/>
           </a:p>
@@ -4113,7 +4119,7 @@
         </p:blipFill>
         <p:spPr>
           <a:xfrm>
-            <a:off x="6335858" y="221095"/>
+            <a:off x="8874039" y="221095"/>
             <a:ext cx="2227349" cy="3133292"/>
           </a:xfrm>
           <a:prstGeom prst="rect">
@@ -4143,7 +4149,7 @@
         </p:blipFill>
         <p:spPr>
           <a:xfrm>
-            <a:off x="5706728" y="2597726"/>
+            <a:off x="5862924" y="2593406"/>
             <a:ext cx="629130" cy="591129"/>
           </a:xfrm>
           <a:prstGeom prst="rect">
@@ -4165,7 +4171,7 @@
         </p:nvSpPr>
         <p:spPr>
           <a:xfrm>
-            <a:off x="5681954" y="399978"/>
+            <a:off x="5495531" y="351705"/>
             <a:ext cx="577402" cy="461665"/>
           </a:xfrm>
           <a:prstGeom prst="rect">
@@ -4205,7 +4211,7 @@
         </p:nvSpPr>
         <p:spPr>
           <a:xfrm>
-            <a:off x="6608236" y="3318948"/>
+            <a:off x="9146417" y="3318948"/>
             <a:ext cx="1881080" cy="369332"/>
           </a:xfrm>
           <a:prstGeom prst="rect">
@@ -4373,7 +4379,7 @@
         </p:nvSpPr>
         <p:spPr>
           <a:xfrm>
-            <a:off x="6259356" y="3890141"/>
+            <a:off x="8797537" y="3890141"/>
             <a:ext cx="6096000" cy="1200329"/>
           </a:xfrm>
           <a:prstGeom prst="rect">
@@ -4412,10 +4418,732 @@
           </a:p>
         </p:txBody>
       </p:sp>
+      <p:pic>
+        <p:nvPicPr>
+          <p:cNvPr id="3" name="图片 2">
+            <a:extLst>
+              <a:ext uri="{FF2B5EF4-FFF2-40B4-BE49-F238E27FC236}">
+                <a16:creationId xmlns:a16="http://schemas.microsoft.com/office/drawing/2014/main" id="{D1A91B9F-1CF0-4422-81EE-2E3BDF4ACF2F}"/>
+              </a:ext>
+            </a:extLst>
+          </p:cNvPr>
+          <p:cNvPicPr>
+            <a:picLocks noChangeAspect="1"/>
+          </p:cNvPicPr>
+          <p:nvPr/>
+        </p:nvPicPr>
+        <p:blipFill>
+          <a:blip r:embed="rId5"/>
+          <a:stretch>
+            <a:fillRect/>
+          </a:stretch>
+        </p:blipFill>
+        <p:spPr>
+          <a:xfrm>
+            <a:off x="6613004" y="309099"/>
+            <a:ext cx="2291861" cy="3045288"/>
+          </a:xfrm>
+          <a:prstGeom prst="rect">
+            <a:avLst/>
+          </a:prstGeom>
+        </p:spPr>
+      </p:pic>
+      <p:sp>
+        <p:nvSpPr>
+          <p:cNvPr id="14" name="文本框 13">
+            <a:extLst>
+              <a:ext uri="{FF2B5EF4-FFF2-40B4-BE49-F238E27FC236}">
+                <a16:creationId xmlns:a16="http://schemas.microsoft.com/office/drawing/2014/main" id="{F9DE4495-9693-47FD-89DC-BF9113C8F4AE}"/>
+              </a:ext>
+            </a:extLst>
+          </p:cNvPr>
+          <p:cNvSpPr txBox="1"/>
+          <p:nvPr/>
+        </p:nvSpPr>
+        <p:spPr>
+          <a:xfrm>
+            <a:off x="7230846" y="3318948"/>
+            <a:ext cx="1140643" cy="369332"/>
+          </a:xfrm>
+          <a:prstGeom prst="rect">
+            <a:avLst/>
+          </a:prstGeom>
+          <a:noFill/>
+        </p:spPr>
+        <p:txBody>
+          <a:bodyPr wrap="square">
+            <a:spAutoFit/>
+          </a:bodyPr>
+          <a:lstStyle/>
+          <a:p>
+            <a:r>
+              <a:rPr lang="en-US" altLang="zh-CN" sz="1800" b="1" dirty="0">
+                <a:solidFill>
+                  <a:sysClr val="windowText" lastClr="000000"/>
+                </a:solidFill>
+                <a:latin typeface="Times New Roman" panose="02020603050405020304" pitchFamily="18" charset="0"/>
+                <a:cs typeface="Times New Roman" panose="02020603050405020304" pitchFamily="18" charset="0"/>
+              </a:rPr>
+              <a:t>Li</a:t>
+            </a:r>
+            <a:r>
+              <a:rPr lang="en-US" altLang="zh-CN" sz="1800" b="1" baseline="-25000" dirty="0">
+                <a:solidFill>
+                  <a:sysClr val="windowText" lastClr="000000"/>
+                </a:solidFill>
+                <a:latin typeface="Times New Roman" panose="02020603050405020304" pitchFamily="18" charset="0"/>
+                <a:cs typeface="Times New Roman" panose="02020603050405020304" pitchFamily="18" charset="0"/>
+              </a:rPr>
+              <a:t>6</a:t>
+            </a:r>
+            <a:r>
+              <a:rPr lang="en-US" altLang="zh-CN" sz="1800" b="1" dirty="0">
+                <a:solidFill>
+                  <a:sysClr val="windowText" lastClr="000000"/>
+                </a:solidFill>
+                <a:latin typeface="Times New Roman" panose="02020603050405020304" pitchFamily="18" charset="0"/>
+                <a:cs typeface="Times New Roman" panose="02020603050405020304" pitchFamily="18" charset="0"/>
+              </a:rPr>
+              <a:t>PS</a:t>
+            </a:r>
+            <a:r>
+              <a:rPr lang="en-US" altLang="zh-CN" sz="1800" b="1" baseline="-25000" dirty="0">
+                <a:solidFill>
+                  <a:sysClr val="windowText" lastClr="000000"/>
+                </a:solidFill>
+                <a:latin typeface="Times New Roman" panose="02020603050405020304" pitchFamily="18" charset="0"/>
+                <a:cs typeface="Times New Roman" panose="02020603050405020304" pitchFamily="18" charset="0"/>
+              </a:rPr>
+              <a:t>5</a:t>
+            </a:r>
+            <a:r>
+              <a:rPr lang="en-US" altLang="zh-CN" sz="1800" b="1" dirty="0">
+                <a:solidFill>
+                  <a:sysClr val="windowText" lastClr="000000"/>
+                </a:solidFill>
+                <a:latin typeface="Times New Roman" panose="02020603050405020304" pitchFamily="18" charset="0"/>
+                <a:cs typeface="Times New Roman" panose="02020603050405020304" pitchFamily="18" charset="0"/>
+              </a:rPr>
+              <a:t>Cl</a:t>
+            </a:r>
+            <a:endParaRPr lang="zh-CN" altLang="en-US" b="1" dirty="0"/>
+          </a:p>
+        </p:txBody>
+      </p:sp>
     </p:spTree>
     <p:extLst>
       <p:ext uri="{BB962C8B-B14F-4D97-AF65-F5344CB8AC3E}">
         <p14:creationId xmlns:p14="http://schemas.microsoft.com/office/powerpoint/2010/main" val="3452370513"/>
+      </p:ext>
+    </p:extLst>
+  </p:cSld>
+  <p:clrMapOvr>
+    <a:masterClrMapping/>
+  </p:clrMapOvr>
+</p:sld>
+</file>
+
+<file path=ppt/slides/slide2.xml><?xml version="1.0" encoding="utf-8"?>
+<p:sld xmlns:a="http://schemas.openxmlformats.org/drawingml/2006/main" xmlns:r="http://schemas.openxmlformats.org/officeDocument/2006/relationships" xmlns:p="http://schemas.openxmlformats.org/presentationml/2006/main">
+  <p:cSld>
+    <p:spTree>
+      <p:nvGrpSpPr>
+        <p:cNvPr id="1" name=""/>
+        <p:cNvGrpSpPr/>
+        <p:nvPr/>
+      </p:nvGrpSpPr>
+      <p:grpSpPr>
+        <a:xfrm>
+          <a:off x="0" y="0"/>
+          <a:ext cx="0" cy="0"/>
+          <a:chOff x="0" y="0"/>
+          <a:chExt cx="0" cy="0"/>
+        </a:xfrm>
+      </p:grpSpPr>
+      <p:sp>
+        <p:nvSpPr>
+          <p:cNvPr id="5" name="文本框 4">
+            <a:extLst>
+              <a:ext uri="{FF2B5EF4-FFF2-40B4-BE49-F238E27FC236}">
+                <a16:creationId xmlns:a16="http://schemas.microsoft.com/office/drawing/2014/main" id="{BEA7E559-6519-4DC4-A9A4-9E2D6710862F}"/>
+              </a:ext>
+            </a:extLst>
+          </p:cNvPr>
+          <p:cNvSpPr txBox="1"/>
+          <p:nvPr/>
+        </p:nvSpPr>
+        <p:spPr>
+          <a:xfrm>
+            <a:off x="5624946" y="4835436"/>
+            <a:ext cx="6096000" cy="1200329"/>
+          </a:xfrm>
+          <a:prstGeom prst="rect">
+            <a:avLst/>
+          </a:prstGeom>
+          <a:noFill/>
+        </p:spPr>
+        <p:txBody>
+          <a:bodyPr wrap="square">
+            <a:spAutoFit/>
+          </a:bodyPr>
+          <a:lstStyle/>
+          <a:p>
+            <a:r>
+              <a:rPr lang="en-US" altLang="zh-CN" dirty="0"/>
+              <a:t>Percolation barriers:</a:t>
+            </a:r>
+          </a:p>
+          <a:p>
+            <a:r>
+              <a:rPr lang="en-US" altLang="zh-CN" dirty="0"/>
+              <a:t>1D percolation barrier is 0.3516 eV</a:t>
+            </a:r>
+          </a:p>
+          <a:p>
+            <a:r>
+              <a:rPr lang="en-US" altLang="zh-CN" dirty="0"/>
+              <a:t>2D percolation barrier is 0.3516 eV</a:t>
+            </a:r>
+          </a:p>
+          <a:p>
+            <a:r>
+              <a:rPr lang="en-US" altLang="zh-CN" dirty="0"/>
+              <a:t>3D percolation barrier is 0.4102 eV</a:t>
+            </a:r>
+            <a:endParaRPr lang="zh-CN" altLang="en-US" dirty="0"/>
+          </a:p>
+        </p:txBody>
+      </p:sp>
+      <p:pic>
+        <p:nvPicPr>
+          <p:cNvPr id="8" name="图片 7">
+            <a:extLst>
+              <a:ext uri="{FF2B5EF4-FFF2-40B4-BE49-F238E27FC236}">
+                <a16:creationId xmlns:a16="http://schemas.microsoft.com/office/drawing/2014/main" id="{E5D624AA-8F62-497D-AE30-ECC3FA6553F3}"/>
+              </a:ext>
+            </a:extLst>
+          </p:cNvPr>
+          <p:cNvPicPr>
+            <a:picLocks noChangeAspect="1"/>
+          </p:cNvPicPr>
+          <p:nvPr/>
+        </p:nvPicPr>
+        <p:blipFill>
+          <a:blip r:embed="rId2"/>
+          <a:stretch>
+            <a:fillRect/>
+          </a:stretch>
+        </p:blipFill>
+        <p:spPr>
+          <a:xfrm>
+            <a:off x="6093606" y="1261951"/>
+            <a:ext cx="2227349" cy="3133292"/>
+          </a:xfrm>
+          <a:prstGeom prst="rect">
+            <a:avLst/>
+          </a:prstGeom>
+        </p:spPr>
+      </p:pic>
+      <p:sp>
+        <p:nvSpPr>
+          <p:cNvPr id="9" name="文本框 8">
+            <a:extLst>
+              <a:ext uri="{FF2B5EF4-FFF2-40B4-BE49-F238E27FC236}">
+                <a16:creationId xmlns:a16="http://schemas.microsoft.com/office/drawing/2014/main" id="{A146EFB5-CEA2-47DD-A818-53FB9E6254E9}"/>
+              </a:ext>
+            </a:extLst>
+          </p:cNvPr>
+          <p:cNvSpPr txBox="1"/>
+          <p:nvPr/>
+        </p:nvSpPr>
+        <p:spPr>
+          <a:xfrm>
+            <a:off x="6365984" y="4359804"/>
+            <a:ext cx="1881080" cy="369332"/>
+          </a:xfrm>
+          <a:prstGeom prst="rect">
+            <a:avLst/>
+          </a:prstGeom>
+          <a:noFill/>
+        </p:spPr>
+        <p:txBody>
+          <a:bodyPr wrap="square">
+            <a:spAutoFit/>
+          </a:bodyPr>
+          <a:lstStyle/>
+          <a:p>
+            <a:r>
+              <a:rPr kumimoji="0" lang="en-US" altLang="zh-CN" sz="1800" b="1" i="0" u="none" strike="noStrike" kern="1200" cap="none" spc="0" normalizeH="0" baseline="0" noProof="0" dirty="0">
+                <a:ln>
+                  <a:noFill/>
+                </a:ln>
+                <a:solidFill>
+                  <a:sysClr val="windowText" lastClr="000000"/>
+                </a:solidFill>
+                <a:effectLst/>
+                <a:uLnTx/>
+                <a:uFillTx/>
+                <a:latin typeface="Times New Roman" panose="02020603050405020304" pitchFamily="18" charset="0"/>
+                <a:ea typeface="等线" panose="02010600030101010101" pitchFamily="2" charset="-122"/>
+                <a:cs typeface="Times New Roman" panose="02020603050405020304" pitchFamily="18" charset="0"/>
+              </a:rPr>
+              <a:t>Li</a:t>
+            </a:r>
+            <a:r>
+              <a:rPr kumimoji="0" lang="en-US" altLang="zh-CN" sz="1800" b="1" i="0" u="none" strike="noStrike" kern="1200" cap="none" spc="0" normalizeH="0" baseline="-25000" noProof="0" dirty="0">
+                <a:ln>
+                  <a:noFill/>
+                </a:ln>
+                <a:solidFill>
+                  <a:sysClr val="windowText" lastClr="000000"/>
+                </a:solidFill>
+                <a:effectLst/>
+                <a:uLnTx/>
+                <a:uFillTx/>
+                <a:latin typeface="Times New Roman" panose="02020603050405020304" pitchFamily="18" charset="0"/>
+                <a:ea typeface="等线" panose="02010600030101010101" pitchFamily="2" charset="-122"/>
+                <a:cs typeface="Times New Roman" panose="02020603050405020304" pitchFamily="18" charset="0"/>
+              </a:rPr>
+              <a:t>6</a:t>
+            </a:r>
+            <a:r>
+              <a:rPr kumimoji="0" lang="en-US" altLang="zh-CN" sz="1800" b="1" i="0" u="none" strike="noStrike" kern="1200" cap="none" spc="0" normalizeH="0" baseline="0" noProof="0" dirty="0">
+                <a:ln>
+                  <a:noFill/>
+                </a:ln>
+                <a:solidFill>
+                  <a:sysClr val="windowText" lastClr="000000"/>
+                </a:solidFill>
+                <a:effectLst/>
+                <a:uLnTx/>
+                <a:uFillTx/>
+                <a:latin typeface="Times New Roman" panose="02020603050405020304" pitchFamily="18" charset="0"/>
+                <a:ea typeface="等线" panose="02010600030101010101" pitchFamily="2" charset="-122"/>
+                <a:cs typeface="Times New Roman" panose="02020603050405020304" pitchFamily="18" charset="0"/>
+              </a:rPr>
+              <a:t>PS</a:t>
+            </a:r>
+            <a:r>
+              <a:rPr kumimoji="0" lang="en-US" altLang="zh-CN" sz="1800" b="1" i="0" u="none" strike="noStrike" kern="1200" cap="none" spc="0" normalizeH="0" baseline="-25000" noProof="0" dirty="0">
+                <a:ln>
+                  <a:noFill/>
+                </a:ln>
+                <a:solidFill>
+                  <a:sysClr val="windowText" lastClr="000000"/>
+                </a:solidFill>
+                <a:effectLst/>
+                <a:uLnTx/>
+                <a:uFillTx/>
+                <a:latin typeface="Times New Roman" panose="02020603050405020304" pitchFamily="18" charset="0"/>
+                <a:ea typeface="等线" panose="02010600030101010101" pitchFamily="2" charset="-122"/>
+                <a:cs typeface="Times New Roman" panose="02020603050405020304" pitchFamily="18" charset="0"/>
+              </a:rPr>
+              <a:t>5</a:t>
+            </a:r>
+            <a:r>
+              <a:rPr kumimoji="0" lang="en-US" altLang="zh-CN" sz="1800" b="1" i="0" u="none" strike="noStrike" kern="1200" cap="none" spc="0" normalizeH="0" baseline="0" noProof="0" dirty="0">
+                <a:ln>
+                  <a:noFill/>
+                </a:ln>
+                <a:solidFill>
+                  <a:sysClr val="windowText" lastClr="000000"/>
+                </a:solidFill>
+                <a:effectLst/>
+                <a:uLnTx/>
+                <a:uFillTx/>
+                <a:latin typeface="Times New Roman" panose="02020603050405020304" pitchFamily="18" charset="0"/>
+                <a:ea typeface="等线" panose="02010600030101010101" pitchFamily="2" charset="-122"/>
+                <a:cs typeface="Times New Roman" panose="02020603050405020304" pitchFamily="18" charset="0"/>
+              </a:rPr>
+              <a:t>Cl</a:t>
+            </a:r>
+            <a:r>
+              <a:rPr kumimoji="0" lang="en-US" altLang="zh-CN" sz="1800" b="1" i="0" u="none" strike="noStrike" kern="1200" cap="none" spc="0" normalizeH="0" baseline="-25000" noProof="0" dirty="0">
+                <a:ln>
+                  <a:noFill/>
+                </a:ln>
+                <a:solidFill>
+                  <a:sysClr val="windowText" lastClr="000000"/>
+                </a:solidFill>
+                <a:effectLst/>
+                <a:uLnTx/>
+                <a:uFillTx/>
+                <a:latin typeface="Times New Roman" panose="02020603050405020304" pitchFamily="18" charset="0"/>
+                <a:ea typeface="等线" panose="02010600030101010101" pitchFamily="2" charset="-122"/>
+                <a:cs typeface="Times New Roman" panose="02020603050405020304" pitchFamily="18" charset="0"/>
+              </a:rPr>
+              <a:t>0.875</a:t>
+            </a:r>
+            <a:r>
+              <a:rPr kumimoji="0" lang="en-US" altLang="zh-CN" sz="1800" b="1" i="0" u="none" strike="noStrike" kern="1200" cap="none" spc="0" normalizeH="0" baseline="0" noProof="0" dirty="0">
+                <a:ln>
+                  <a:noFill/>
+                </a:ln>
+                <a:solidFill>
+                  <a:sysClr val="windowText" lastClr="000000"/>
+                </a:solidFill>
+                <a:effectLst/>
+                <a:uLnTx/>
+                <a:uFillTx/>
+                <a:latin typeface="Times New Roman" panose="02020603050405020304" pitchFamily="18" charset="0"/>
+                <a:ea typeface="等线" panose="02010600030101010101" pitchFamily="2" charset="-122"/>
+                <a:cs typeface="Times New Roman" panose="02020603050405020304" pitchFamily="18" charset="0"/>
+              </a:rPr>
+              <a:t>I</a:t>
+            </a:r>
+            <a:r>
+              <a:rPr kumimoji="0" lang="en-US" altLang="zh-CN" sz="1800" b="1" i="0" u="none" strike="noStrike" kern="1200" cap="none" spc="0" normalizeH="0" baseline="-25000" noProof="0" dirty="0">
+                <a:ln>
+                  <a:noFill/>
+                </a:ln>
+                <a:solidFill>
+                  <a:sysClr val="windowText" lastClr="000000"/>
+                </a:solidFill>
+                <a:effectLst/>
+                <a:uLnTx/>
+                <a:uFillTx/>
+                <a:latin typeface="Times New Roman" panose="02020603050405020304" pitchFamily="18" charset="0"/>
+                <a:ea typeface="等线" panose="02010600030101010101" pitchFamily="2" charset="-122"/>
+                <a:cs typeface="Times New Roman" panose="02020603050405020304" pitchFamily="18" charset="0"/>
+              </a:rPr>
+              <a:t>0.125</a:t>
+            </a:r>
+            <a:endParaRPr lang="zh-CN" altLang="en-US" baseline="-25000" dirty="0"/>
+          </a:p>
+        </p:txBody>
+      </p:sp>
+      <p:sp>
+        <p:nvSpPr>
+          <p:cNvPr id="11" name="文本框 10">
+            <a:extLst>
+              <a:ext uri="{FF2B5EF4-FFF2-40B4-BE49-F238E27FC236}">
+                <a16:creationId xmlns:a16="http://schemas.microsoft.com/office/drawing/2014/main" id="{1C39FF8E-3260-4648-BB14-DBD2CEDEF0B7}"/>
+              </a:ext>
+            </a:extLst>
+          </p:cNvPr>
+          <p:cNvSpPr txBox="1"/>
+          <p:nvPr/>
+        </p:nvSpPr>
+        <p:spPr>
+          <a:xfrm>
+            <a:off x="2197028" y="4359804"/>
+            <a:ext cx="1140643" cy="369332"/>
+          </a:xfrm>
+          <a:prstGeom prst="rect">
+            <a:avLst/>
+          </a:prstGeom>
+          <a:noFill/>
+        </p:spPr>
+        <p:txBody>
+          <a:bodyPr wrap="square">
+            <a:spAutoFit/>
+          </a:bodyPr>
+          <a:lstStyle/>
+          <a:p>
+            <a:r>
+              <a:rPr lang="en-US" altLang="zh-CN" sz="1800" b="1" dirty="0">
+                <a:solidFill>
+                  <a:sysClr val="windowText" lastClr="000000"/>
+                </a:solidFill>
+                <a:latin typeface="Times New Roman" panose="02020603050405020304" pitchFamily="18" charset="0"/>
+                <a:cs typeface="Times New Roman" panose="02020603050405020304" pitchFamily="18" charset="0"/>
+              </a:rPr>
+              <a:t>Li</a:t>
+            </a:r>
+            <a:r>
+              <a:rPr lang="en-US" altLang="zh-CN" sz="1800" b="1" baseline="-25000" dirty="0">
+                <a:solidFill>
+                  <a:sysClr val="windowText" lastClr="000000"/>
+                </a:solidFill>
+                <a:latin typeface="Times New Roman" panose="02020603050405020304" pitchFamily="18" charset="0"/>
+                <a:cs typeface="Times New Roman" panose="02020603050405020304" pitchFamily="18" charset="0"/>
+              </a:rPr>
+              <a:t>6</a:t>
+            </a:r>
+            <a:r>
+              <a:rPr lang="en-US" altLang="zh-CN" sz="1800" b="1" dirty="0">
+                <a:solidFill>
+                  <a:sysClr val="windowText" lastClr="000000"/>
+                </a:solidFill>
+                <a:latin typeface="Times New Roman" panose="02020603050405020304" pitchFamily="18" charset="0"/>
+                <a:cs typeface="Times New Roman" panose="02020603050405020304" pitchFamily="18" charset="0"/>
+              </a:rPr>
+              <a:t>PS</a:t>
+            </a:r>
+            <a:r>
+              <a:rPr lang="en-US" altLang="zh-CN" sz="1800" b="1" baseline="-25000" dirty="0">
+                <a:solidFill>
+                  <a:sysClr val="windowText" lastClr="000000"/>
+                </a:solidFill>
+                <a:latin typeface="Times New Roman" panose="02020603050405020304" pitchFamily="18" charset="0"/>
+                <a:cs typeface="Times New Roman" panose="02020603050405020304" pitchFamily="18" charset="0"/>
+              </a:rPr>
+              <a:t>5</a:t>
+            </a:r>
+            <a:r>
+              <a:rPr lang="en-US" altLang="zh-CN" sz="1800" b="1" dirty="0">
+                <a:solidFill>
+                  <a:sysClr val="windowText" lastClr="000000"/>
+                </a:solidFill>
+                <a:latin typeface="Times New Roman" panose="02020603050405020304" pitchFamily="18" charset="0"/>
+                <a:cs typeface="Times New Roman" panose="02020603050405020304" pitchFamily="18" charset="0"/>
+              </a:rPr>
+              <a:t>Cl</a:t>
+            </a:r>
+            <a:endParaRPr lang="zh-CN" altLang="en-US" b="1" dirty="0"/>
+          </a:p>
+        </p:txBody>
+      </p:sp>
+      <p:sp>
+        <p:nvSpPr>
+          <p:cNvPr id="13" name="文本框 12">
+            <a:extLst>
+              <a:ext uri="{FF2B5EF4-FFF2-40B4-BE49-F238E27FC236}">
+                <a16:creationId xmlns:a16="http://schemas.microsoft.com/office/drawing/2014/main" id="{1FE26762-344F-4551-85DF-EA9EBB152E6B}"/>
+              </a:ext>
+            </a:extLst>
+          </p:cNvPr>
+          <p:cNvSpPr txBox="1"/>
+          <p:nvPr/>
+        </p:nvSpPr>
+        <p:spPr>
+          <a:xfrm>
+            <a:off x="1347235" y="4812544"/>
+            <a:ext cx="3980872" cy="1200329"/>
+          </a:xfrm>
+          <a:prstGeom prst="rect">
+            <a:avLst/>
+          </a:prstGeom>
+          <a:noFill/>
+        </p:spPr>
+        <p:txBody>
+          <a:bodyPr wrap="square">
+            <a:spAutoFit/>
+          </a:bodyPr>
+          <a:lstStyle/>
+          <a:p>
+            <a:r>
+              <a:rPr lang="en-US" altLang="zh-CN" dirty="0"/>
+              <a:t>Percolation barriers:</a:t>
+            </a:r>
+          </a:p>
+          <a:p>
+            <a:r>
+              <a:rPr lang="en-US" altLang="zh-CN" dirty="0"/>
+              <a:t>1D percolation barrier is 0.3711 eV</a:t>
+            </a:r>
+          </a:p>
+          <a:p>
+            <a:r>
+              <a:rPr lang="en-US" altLang="zh-CN" dirty="0"/>
+              <a:t>2D percolation barrier is 0.3711 eV</a:t>
+            </a:r>
+          </a:p>
+          <a:p>
+            <a:r>
+              <a:rPr lang="en-US" altLang="zh-CN" dirty="0"/>
+              <a:t>3D percolation barrier is 0.4004 eV</a:t>
+            </a:r>
+            <a:endParaRPr lang="zh-CN" altLang="en-US" dirty="0"/>
+          </a:p>
+        </p:txBody>
+      </p:sp>
+      <p:pic>
+        <p:nvPicPr>
+          <p:cNvPr id="17" name="图片 16">
+            <a:extLst>
+              <a:ext uri="{FF2B5EF4-FFF2-40B4-BE49-F238E27FC236}">
+                <a16:creationId xmlns:a16="http://schemas.microsoft.com/office/drawing/2014/main" id="{D848A179-DD5C-4462-8BCB-A14547A3D757}"/>
+              </a:ext>
+            </a:extLst>
+          </p:cNvPr>
+          <p:cNvPicPr>
+            <a:picLocks noChangeAspect="1"/>
+          </p:cNvPicPr>
+          <p:nvPr/>
+        </p:nvPicPr>
+        <p:blipFill>
+          <a:blip r:embed="rId3"/>
+          <a:stretch>
+            <a:fillRect/>
+          </a:stretch>
+        </p:blipFill>
+        <p:spPr>
+          <a:xfrm>
+            <a:off x="1780014" y="1261950"/>
+            <a:ext cx="2035496" cy="3133292"/>
+          </a:xfrm>
+          <a:prstGeom prst="rect">
+            <a:avLst/>
+          </a:prstGeom>
+        </p:spPr>
+      </p:pic>
+      <p:sp>
+        <p:nvSpPr>
+          <p:cNvPr id="18" name="文本框 17">
+            <a:extLst>
+              <a:ext uri="{FF2B5EF4-FFF2-40B4-BE49-F238E27FC236}">
+                <a16:creationId xmlns:a16="http://schemas.microsoft.com/office/drawing/2014/main" id="{54627152-BC7E-4C76-96A7-690D151C1BCA}"/>
+              </a:ext>
+            </a:extLst>
+          </p:cNvPr>
+          <p:cNvSpPr txBox="1"/>
+          <p:nvPr/>
+        </p:nvSpPr>
+        <p:spPr>
+          <a:xfrm>
+            <a:off x="0" y="0"/>
+            <a:ext cx="894797" cy="461665"/>
+          </a:xfrm>
+          <a:prstGeom prst="rect">
+            <a:avLst/>
+          </a:prstGeom>
+          <a:noFill/>
+        </p:spPr>
+        <p:txBody>
+          <a:bodyPr wrap="none" rtlCol="0">
+            <a:spAutoFit/>
+          </a:bodyPr>
+          <a:lstStyle/>
+          <a:p>
+            <a:r>
+              <a:rPr lang="en-US" altLang="zh-CN" sz="2400" b="1" dirty="0"/>
+              <a:t>BVSE</a:t>
+            </a:r>
+            <a:endParaRPr lang="zh-CN" altLang="en-US" sz="2400" b="1" dirty="0"/>
+          </a:p>
+        </p:txBody>
+      </p:sp>
+      <p:sp>
+        <p:nvSpPr>
+          <p:cNvPr id="23" name="文本框 22">
+            <a:extLst>
+              <a:ext uri="{FF2B5EF4-FFF2-40B4-BE49-F238E27FC236}">
+                <a16:creationId xmlns:a16="http://schemas.microsoft.com/office/drawing/2014/main" id="{CBB51050-5F4B-4FB0-B6FD-9CA90A7D12B0}"/>
+              </a:ext>
+            </a:extLst>
+          </p:cNvPr>
+          <p:cNvSpPr txBox="1"/>
+          <p:nvPr/>
+        </p:nvSpPr>
+        <p:spPr>
+          <a:xfrm>
+            <a:off x="816402" y="5953121"/>
+            <a:ext cx="7528766" cy="954107"/>
+          </a:xfrm>
+          <a:prstGeom prst="rect">
+            <a:avLst/>
+          </a:prstGeom>
+          <a:noFill/>
+        </p:spPr>
+        <p:txBody>
+          <a:bodyPr wrap="square">
+            <a:spAutoFit/>
+          </a:bodyPr>
+          <a:lstStyle/>
+          <a:p>
+            <a:r>
+              <a:rPr lang="en-US" altLang="zh-CN" sz="1400" dirty="0"/>
+              <a:t>	</a:t>
+            </a:r>
+            <a:r>
+              <a:rPr lang="en-US" altLang="zh-CN" sz="1400" dirty="0" err="1"/>
+              <a:t>parser.add_argument</a:t>
+            </a:r>
+            <a:r>
+              <a:rPr lang="en-US" altLang="zh-CN" sz="1400" dirty="0"/>
+              <a:t>("--r-cut", type=float, default=8.0, help="</a:t>
+            </a:r>
+            <a:r>
+              <a:rPr lang="zh-CN" altLang="en-US" sz="1400" dirty="0"/>
+              <a:t>截断半径，</a:t>
+            </a:r>
+            <a:r>
+              <a:rPr lang="en-US" altLang="zh-CN" sz="1400" dirty="0"/>
+              <a:t>")</a:t>
+            </a:r>
+          </a:p>
+          <a:p>
+            <a:r>
+              <a:rPr lang="en-US" altLang="zh-CN" sz="1400" dirty="0"/>
+              <a:t>	</a:t>
+            </a:r>
+            <a:r>
+              <a:rPr lang="en-US" altLang="zh-CN" sz="1400" dirty="0" err="1"/>
+              <a:t>parser.add_argument</a:t>
+            </a:r>
+            <a:r>
+              <a:rPr lang="en-US" altLang="zh-CN" sz="1400" dirty="0"/>
+              <a:t>("--resolution", type=float, default=0.3, help="</a:t>
+            </a:r>
+            <a:r>
+              <a:rPr lang="zh-CN" altLang="en-US" sz="1400" dirty="0"/>
+              <a:t>网格分辨率</a:t>
+            </a:r>
+            <a:r>
+              <a:rPr lang="en-US" altLang="zh-CN" sz="1400" dirty="0"/>
+              <a:t>)</a:t>
+            </a:r>
+          </a:p>
+          <a:p>
+            <a:r>
+              <a:rPr lang="en-US" altLang="zh-CN" sz="1400" dirty="0"/>
+              <a:t>	</a:t>
+            </a:r>
+            <a:r>
+              <a:rPr lang="en-US" altLang="zh-CN" sz="1400" dirty="0" err="1"/>
+              <a:t>parser.add_argument</a:t>
+            </a:r>
+            <a:r>
+              <a:rPr lang="en-US" altLang="zh-CN" sz="1400" dirty="0"/>
+              <a:t>("--k", type=int, default=100, help="</a:t>
+            </a:r>
+            <a:r>
+              <a:rPr lang="zh-CN" altLang="en-US" sz="1400" dirty="0"/>
+              <a:t>近邻搜索个数上限</a:t>
+            </a:r>
+            <a:r>
+              <a:rPr lang="en-US" altLang="zh-CN" sz="1400" dirty="0"/>
+              <a:t>)</a:t>
+            </a:r>
+          </a:p>
+          <a:p>
+            <a:r>
+              <a:rPr lang="en-US" altLang="zh-CN" sz="1400" dirty="0"/>
+              <a:t>	</a:t>
+            </a:r>
+            <a:r>
+              <a:rPr lang="en-US" altLang="zh-CN" sz="1400" dirty="0" err="1"/>
+              <a:t>parser.add_argument</a:t>
+            </a:r>
+            <a:r>
+              <a:rPr lang="en-US" altLang="zh-CN" sz="1400" dirty="0"/>
+              <a:t>("--</a:t>
+            </a:r>
+            <a:r>
+              <a:rPr lang="en-US" altLang="zh-CN" sz="1400" dirty="0" err="1"/>
+              <a:t>encut</a:t>
+            </a:r>
+            <a:r>
+              <a:rPr lang="en-US" altLang="zh-CN" sz="1400" dirty="0"/>
+              <a:t>", type=float, default=5.0, help="</a:t>
+            </a:r>
+            <a:r>
+              <a:rPr lang="zh-CN" altLang="en-US" sz="1400" dirty="0"/>
+              <a:t>渗流势垒能量截断</a:t>
+            </a:r>
+            <a:r>
+              <a:rPr lang="en-US" altLang="zh-CN" sz="1400" dirty="0"/>
+              <a:t>)</a:t>
+            </a:r>
+            <a:endParaRPr lang="zh-CN" altLang="en-US" sz="1400" dirty="0"/>
+          </a:p>
+        </p:txBody>
+      </p:sp>
+    </p:spTree>
+    <p:extLst>
+      <p:ext uri="{BB962C8B-B14F-4D97-AF65-F5344CB8AC3E}">
+        <p14:creationId xmlns:p14="http://schemas.microsoft.com/office/powerpoint/2010/main" val="2643185768"/>
       </p:ext>
     </p:extLst>
   </p:cSld>

</xml_diff>